<commit_message>
Mise à jour de la piste de score + début de la mise à jour du livret
</commit_message>
<xml_diff>
--- a/pictures/Score-Track-fr/Design-Piste-Scores.pptx
+++ b/pictures/Score-Track-fr/Design-Piste-Scores.pptx
@@ -198,7 +198,7 @@
           <a:p>
             <a:fld id="{263B0988-6DB9-4E3D-B7FD-EFF3BCABE954}" type="datetimeFigureOut">
               <a:rPr lang="fr-FR" smtClean="0"/>
-              <a:t>16/09/2026</a:t>
+              <a:t>29/09/2026</a:t>
             </a:fld>
             <a:endParaRPr lang="fr-FR"/>
           </a:p>
@@ -696,7 +696,7 @@
           <a:p>
             <a:fld id="{588505E2-0C4C-443F-8F57-41958F504CA2}" type="datetimeFigureOut">
               <a:rPr lang="fr-FR" smtClean="0"/>
-              <a:t>16/09/2026</a:t>
+              <a:t>29/09/2026</a:t>
             </a:fld>
             <a:endParaRPr lang="fr-FR"/>
           </a:p>
@@ -894,7 +894,7 @@
           <a:p>
             <a:fld id="{588505E2-0C4C-443F-8F57-41958F504CA2}" type="datetimeFigureOut">
               <a:rPr lang="fr-FR" smtClean="0"/>
-              <a:t>16/09/2026</a:t>
+              <a:t>29/09/2026</a:t>
             </a:fld>
             <a:endParaRPr lang="fr-FR"/>
           </a:p>
@@ -1102,7 +1102,7 @@
           <a:p>
             <a:fld id="{588505E2-0C4C-443F-8F57-41958F504CA2}" type="datetimeFigureOut">
               <a:rPr lang="fr-FR" smtClean="0"/>
-              <a:t>16/09/2026</a:t>
+              <a:t>29/09/2026</a:t>
             </a:fld>
             <a:endParaRPr lang="fr-FR"/>
           </a:p>
@@ -1300,7 +1300,7 @@
           <a:p>
             <a:fld id="{588505E2-0C4C-443F-8F57-41958F504CA2}" type="datetimeFigureOut">
               <a:rPr lang="fr-FR" smtClean="0"/>
-              <a:t>16/09/2026</a:t>
+              <a:t>29/09/2026</a:t>
             </a:fld>
             <a:endParaRPr lang="fr-FR"/>
           </a:p>
@@ -1575,7 +1575,7 @@
           <a:p>
             <a:fld id="{588505E2-0C4C-443F-8F57-41958F504CA2}" type="datetimeFigureOut">
               <a:rPr lang="fr-FR" smtClean="0"/>
-              <a:t>16/09/2026</a:t>
+              <a:t>29/09/2026</a:t>
             </a:fld>
             <a:endParaRPr lang="fr-FR"/>
           </a:p>
@@ -1840,7 +1840,7 @@
           <a:p>
             <a:fld id="{588505E2-0C4C-443F-8F57-41958F504CA2}" type="datetimeFigureOut">
               <a:rPr lang="fr-FR" smtClean="0"/>
-              <a:t>16/09/2026</a:t>
+              <a:t>29/09/2026</a:t>
             </a:fld>
             <a:endParaRPr lang="fr-FR"/>
           </a:p>
@@ -2252,7 +2252,7 @@
           <a:p>
             <a:fld id="{588505E2-0C4C-443F-8F57-41958F504CA2}" type="datetimeFigureOut">
               <a:rPr lang="fr-FR" smtClean="0"/>
-              <a:t>16/09/2026</a:t>
+              <a:t>29/09/2026</a:t>
             </a:fld>
             <a:endParaRPr lang="fr-FR"/>
           </a:p>
@@ -2393,7 +2393,7 @@
           <a:p>
             <a:fld id="{588505E2-0C4C-443F-8F57-41958F504CA2}" type="datetimeFigureOut">
               <a:rPr lang="fr-FR" smtClean="0"/>
-              <a:t>16/09/2026</a:t>
+              <a:t>29/09/2026</a:t>
             </a:fld>
             <a:endParaRPr lang="fr-FR"/>
           </a:p>
@@ -2506,7 +2506,7 @@
           <a:p>
             <a:fld id="{588505E2-0C4C-443F-8F57-41958F504CA2}" type="datetimeFigureOut">
               <a:rPr lang="fr-FR" smtClean="0"/>
-              <a:t>16/09/2026</a:t>
+              <a:t>29/09/2026</a:t>
             </a:fld>
             <a:endParaRPr lang="fr-FR"/>
           </a:p>
@@ -2817,7 +2817,7 @@
           <a:p>
             <a:fld id="{588505E2-0C4C-443F-8F57-41958F504CA2}" type="datetimeFigureOut">
               <a:rPr lang="fr-FR" smtClean="0"/>
-              <a:t>16/09/2026</a:t>
+              <a:t>29/09/2026</a:t>
             </a:fld>
             <a:endParaRPr lang="fr-FR"/>
           </a:p>
@@ -3105,7 +3105,7 @@
           <a:p>
             <a:fld id="{588505E2-0C4C-443F-8F57-41958F504CA2}" type="datetimeFigureOut">
               <a:rPr lang="fr-FR" smtClean="0"/>
-              <a:t>16/09/2026</a:t>
+              <a:t>29/09/2026</a:t>
             </a:fld>
             <a:endParaRPr lang="fr-FR"/>
           </a:p>
@@ -3346,7 +3346,7 @@
           <a:p>
             <a:fld id="{588505E2-0C4C-443F-8F57-41958F504CA2}" type="datetimeFigureOut">
               <a:rPr lang="fr-FR" smtClean="0"/>
-              <a:t>16/09/2026</a:t>
+              <a:t>29/09/2026</a:t>
             </a:fld>
             <a:endParaRPr lang="fr-FR"/>
           </a:p>
@@ -3771,10 +3771,10 @@
       </p:grpSpPr>
       <p:grpSp>
         <p:nvGrpSpPr>
-          <p:cNvPr id="12" name="Groupe 11">
+          <p:cNvPr id="15" name="Groupe 14">
             <a:extLst>
               <a:ext uri="{FF2B5EF4-FFF2-40B4-BE49-F238E27FC236}">
-                <a16:creationId xmlns:a16="http://schemas.microsoft.com/office/drawing/2014/main" id="{2E40BB44-66DC-7D3E-DC30-2C241F3E36C3}"/>
+                <a16:creationId xmlns:a16="http://schemas.microsoft.com/office/drawing/2014/main" id="{9B2F6160-87F6-4B54-F1BB-D92FF71DCEA6}"/>
               </a:ext>
             </a:extLst>
           </p:cNvPr>
@@ -3970,7 +3970,7 @@
           </p:nvSpPr>
           <p:spPr>
             <a:xfrm>
-              <a:off x="2813734" y="2080613"/>
+              <a:off x="2813734" y="1157069"/>
               <a:ext cx="492125" cy="466725"/>
             </a:xfrm>
             <a:prstGeom prst="cube">
@@ -4066,7 +4066,7 @@
           </p:nvSpPr>
           <p:spPr>
             <a:xfrm>
-              <a:off x="2813734" y="2653372"/>
+              <a:off x="2813734" y="1729828"/>
               <a:ext cx="491490" cy="466725"/>
             </a:xfrm>
             <a:prstGeom prst="cube">
@@ -4162,7 +4162,7 @@
           </p:nvSpPr>
           <p:spPr>
             <a:xfrm>
-              <a:off x="2572700" y="3226131"/>
+              <a:off x="2572700" y="2302587"/>
               <a:ext cx="973558" cy="852837"/>
             </a:xfrm>
             <a:prstGeom prst="hexagon">
@@ -7680,14 +7680,14 @@
                   <a:latin typeface="Segoe UI" panose="020B0502040204020203" pitchFamily="34" charset="0"/>
                   <a:cs typeface="Segoe UI" panose="020B0502040204020203" pitchFamily="34" charset="0"/>
                 </a:rPr>
-                <a:t>0 carte </a:t>
+                <a:t>5 cartes </a:t>
               </a:r>
               <a:r>
                 <a:rPr lang="fr-FR" sz="1200" b="1" dirty="0">
                   <a:latin typeface="Segoe UI" panose="020B0502040204020203" pitchFamily="34" charset="0"/>
                   <a:cs typeface="Segoe UI" panose="020B0502040204020203" pitchFamily="34" charset="0"/>
                 </a:rPr>
-                <a:t>en main </a:t>
+                <a:t>ou moins </a:t>
               </a:r>
               <a:r>
                 <a:rPr lang="fr-FR" sz="1200" b="1" dirty="0">
@@ -7718,6 +7718,318 @@
             </a:p>
           </p:txBody>
         </p:sp>
+        <p:grpSp>
+          <p:nvGrpSpPr>
+            <p:cNvPr id="14" name="Groupe 13">
+              <a:extLst>
+                <a:ext uri="{FF2B5EF4-FFF2-40B4-BE49-F238E27FC236}">
+                  <a16:creationId xmlns:a16="http://schemas.microsoft.com/office/drawing/2014/main" id="{157D7E41-C11E-A5B4-B195-A9D1A097158E}"/>
+                </a:ext>
+              </a:extLst>
+            </p:cNvPr>
+            <p:cNvGrpSpPr/>
+            <p:nvPr/>
+          </p:nvGrpSpPr>
+          <p:grpSpPr>
+            <a:xfrm>
+              <a:off x="2687884" y="3319350"/>
+              <a:ext cx="733464" cy="733464"/>
+              <a:chOff x="785400" y="2979000"/>
+              <a:chExt cx="733464" cy="733464"/>
+            </a:xfrm>
+          </p:grpSpPr>
+          <p:sp>
+            <p:nvSpPr>
+              <p:cNvPr id="3" name="Rectangle 2">
+                <a:extLst>
+                  <a:ext uri="{FF2B5EF4-FFF2-40B4-BE49-F238E27FC236}">
+                    <a16:creationId xmlns:a16="http://schemas.microsoft.com/office/drawing/2014/main" id="{89970D07-6861-D978-C41E-66B7796AEA21}"/>
+                  </a:ext>
+                </a:extLst>
+              </p:cNvPr>
+              <p:cNvSpPr/>
+              <p:nvPr/>
+            </p:nvSpPr>
+            <p:spPr>
+              <a:xfrm>
+                <a:off x="785400" y="2979000"/>
+                <a:ext cx="733464" cy="733464"/>
+              </a:xfrm>
+              <a:prstGeom prst="rect">
+                <a:avLst/>
+              </a:prstGeom>
+              <a:blipFill>
+                <a:blip r:embed="rId4">
+                  <a:duotone>
+                    <a:schemeClr val="bg2">
+                      <a:shade val="45000"/>
+                      <a:satMod val="135000"/>
+                    </a:schemeClr>
+                    <a:prstClr val="white"/>
+                  </a:duotone>
+                  <a:extLst>
+                    <a:ext uri="{BEBA8EAE-BF5A-486C-A8C5-ECC9F3942E4B}">
+                      <a14:imgProps xmlns:a14="http://schemas.microsoft.com/office/drawing/2010/main">
+                        <a14:imgLayer r:embed="rId5">
+                          <a14:imgEffect>
+                            <a14:artisticWatercolorSponge/>
+                          </a14:imgEffect>
+                          <a14:imgEffect>
+                            <a14:brightnessContrast bright="20000" contrast="-40000"/>
+                          </a14:imgEffect>
+                        </a14:imgLayer>
+                      </a14:imgProps>
+                    </a:ext>
+                  </a:extLst>
+                </a:blip>
+                <a:tile tx="0" ty="0" sx="100000" sy="100000" flip="none" algn="tl"/>
+              </a:blipFill>
+              <a:ln w="19050">
+                <a:solidFill>
+                  <a:schemeClr val="bg1"/>
+                </a:solidFill>
+              </a:ln>
+              <a:scene3d>
+                <a:camera prst="orthographicFront"/>
+                <a:lightRig rig="threePt" dir="t"/>
+              </a:scene3d>
+              <a:sp3d>
+                <a:bevelT w="152400" h="50800" prst="softRound"/>
+              </a:sp3d>
+            </p:spPr>
+            <p:style>
+              <a:lnRef idx="2">
+                <a:schemeClr val="accent1">
+                  <a:shade val="15000"/>
+                </a:schemeClr>
+              </a:lnRef>
+              <a:fillRef idx="1">
+                <a:schemeClr val="accent1"/>
+              </a:fillRef>
+              <a:effectRef idx="0">
+                <a:schemeClr val="accent1"/>
+              </a:effectRef>
+              <a:fontRef idx="minor">
+                <a:schemeClr val="lt1"/>
+              </a:fontRef>
+            </p:style>
+            <p:txBody>
+              <a:bodyPr rot="0" spcFirstLastPara="0" vert="horz" wrap="square" lIns="91440" tIns="45720" rIns="91440" bIns="45720" numCol="1" spcCol="0" rtlCol="0" fromWordArt="0" anchor="t" anchorCtr="0" forceAA="0" compatLnSpc="1">
+                <a:prstTxWarp prst="textNoShape">
+                  <a:avLst/>
+                </a:prstTxWarp>
+                <a:noAutofit/>
+              </a:bodyPr>
+              <a:lstStyle/>
+              <a:p>
+                <a:pPr algn="ctr">
+                  <a:lnSpc>
+                    <a:spcPct val="107000"/>
+                  </a:lnSpc>
+                  <a:spcAft>
+                    <a:spcPts val="800"/>
+                  </a:spcAft>
+                  <a:buNone/>
+                </a:pPr>
+                <a:r>
+                  <a:rPr lang="fr-FR" sz="1400" b="1" dirty="0">
+                    <a:solidFill>
+                      <a:schemeClr val="tx1"/>
+                    </a:solidFill>
+                    <a:effectLst/>
+                    <a:latin typeface="Segoe UI" panose="020B0502040204020203" pitchFamily="34" charset="0"/>
+                    <a:ea typeface="Aptos" panose="020B0004020202020204" pitchFamily="34" charset="0"/>
+                    <a:cs typeface="Segoe UI" panose="020B0502040204020203" pitchFamily="34" charset="0"/>
+                  </a:rPr>
+                  <a:t>+1</a:t>
+                </a:r>
+              </a:p>
+            </p:txBody>
+          </p:sp>
+          <p:grpSp>
+            <p:nvGrpSpPr>
+              <p:cNvPr id="4" name="Groupe 3">
+                <a:extLst>
+                  <a:ext uri="{FF2B5EF4-FFF2-40B4-BE49-F238E27FC236}">
+                    <a16:creationId xmlns:a16="http://schemas.microsoft.com/office/drawing/2014/main" id="{F429085F-D551-4392-DBD4-A75F73CEF6CC}"/>
+                  </a:ext>
+                </a:extLst>
+              </p:cNvPr>
+              <p:cNvGrpSpPr/>
+              <p:nvPr/>
+            </p:nvGrpSpPr>
+            <p:grpSpPr>
+              <a:xfrm>
+                <a:off x="970015" y="3258539"/>
+                <a:ext cx="365900" cy="340921"/>
+                <a:chOff x="1980005" y="1399967"/>
+                <a:chExt cx="365900" cy="340921"/>
+              </a:xfrm>
+            </p:grpSpPr>
+            <p:sp>
+              <p:nvSpPr>
+                <p:cNvPr id="5" name="Ellipse 4">
+                  <a:extLst>
+                    <a:ext uri="{FF2B5EF4-FFF2-40B4-BE49-F238E27FC236}">
+                      <a16:creationId xmlns:a16="http://schemas.microsoft.com/office/drawing/2014/main" id="{2DB2FDB7-9175-49DA-418E-25779DB65221}"/>
+                    </a:ext>
+                  </a:extLst>
+                </p:cNvPr>
+                <p:cNvSpPr>
+                  <a:spLocks noChangeAspect="1"/>
+                </p:cNvSpPr>
+                <p:nvPr/>
+              </p:nvSpPr>
+              <p:spPr>
+                <a:xfrm>
+                  <a:off x="1980005" y="1560888"/>
+                  <a:ext cx="180000" cy="180000"/>
+                </a:xfrm>
+                <a:prstGeom prst="ellipse">
+                  <a:avLst/>
+                </a:prstGeom>
+                <a:noFill/>
+                <a:ln>
+                  <a:solidFill>
+                    <a:schemeClr val="tx1"/>
+                  </a:solidFill>
+                </a:ln>
+              </p:spPr>
+              <p:style>
+                <a:lnRef idx="2">
+                  <a:schemeClr val="accent1">
+                    <a:shade val="15000"/>
+                  </a:schemeClr>
+                </a:lnRef>
+                <a:fillRef idx="1">
+                  <a:schemeClr val="accent1"/>
+                </a:fillRef>
+                <a:effectRef idx="0">
+                  <a:schemeClr val="accent1"/>
+                </a:effectRef>
+                <a:fontRef idx="minor">
+                  <a:schemeClr val="lt1"/>
+                </a:fontRef>
+              </p:style>
+              <p:txBody>
+                <a:bodyPr rtlCol="0" anchor="ctr"/>
+                <a:lstStyle/>
+                <a:p>
+                  <a:pPr algn="ctr"/>
+                  <a:endParaRPr lang="fr-FR"/>
+                </a:p>
+              </p:txBody>
+            </p:sp>
+            <p:sp>
+              <p:nvSpPr>
+                <p:cNvPr id="6" name="Ellipse 5">
+                  <a:extLst>
+                    <a:ext uri="{FF2B5EF4-FFF2-40B4-BE49-F238E27FC236}">
+                      <a16:creationId xmlns:a16="http://schemas.microsoft.com/office/drawing/2014/main" id="{D27968AC-4D11-52B4-F1EC-584EB2D12848}"/>
+                    </a:ext>
+                  </a:extLst>
+                </p:cNvPr>
+                <p:cNvSpPr>
+                  <a:spLocks noChangeAspect="1"/>
+                </p:cNvSpPr>
+                <p:nvPr/>
+              </p:nvSpPr>
+              <p:spPr>
+                <a:xfrm>
+                  <a:off x="2070005" y="1399967"/>
+                  <a:ext cx="180000" cy="180000"/>
+                </a:xfrm>
+                <a:prstGeom prst="ellipse">
+                  <a:avLst/>
+                </a:prstGeom>
+                <a:noFill/>
+                <a:ln>
+                  <a:solidFill>
+                    <a:schemeClr val="tx1"/>
+                  </a:solidFill>
+                </a:ln>
+              </p:spPr>
+              <p:style>
+                <a:lnRef idx="2">
+                  <a:schemeClr val="accent1">
+                    <a:shade val="15000"/>
+                  </a:schemeClr>
+                </a:lnRef>
+                <a:fillRef idx="1">
+                  <a:schemeClr val="accent1"/>
+                </a:fillRef>
+                <a:effectRef idx="0">
+                  <a:schemeClr val="accent1"/>
+                </a:effectRef>
+                <a:fontRef idx="minor">
+                  <a:schemeClr val="lt1"/>
+                </a:fontRef>
+              </p:style>
+              <p:txBody>
+                <a:bodyPr rtlCol="0" anchor="ctr"/>
+                <a:lstStyle/>
+                <a:p>
+                  <a:pPr algn="ctr"/>
+                  <a:endParaRPr lang="fr-FR"/>
+                </a:p>
+              </p:txBody>
+            </p:sp>
+            <p:sp>
+              <p:nvSpPr>
+                <p:cNvPr id="13" name="Ellipse 12">
+                  <a:extLst>
+                    <a:ext uri="{FF2B5EF4-FFF2-40B4-BE49-F238E27FC236}">
+                      <a16:creationId xmlns:a16="http://schemas.microsoft.com/office/drawing/2014/main" id="{997EA58D-49DE-CE56-92AE-DED4CA439786}"/>
+                    </a:ext>
+                  </a:extLst>
+                </p:cNvPr>
+                <p:cNvSpPr>
+                  <a:spLocks noChangeAspect="1"/>
+                </p:cNvSpPr>
+                <p:nvPr/>
+              </p:nvSpPr>
+              <p:spPr>
+                <a:xfrm>
+                  <a:off x="2165905" y="1560888"/>
+                  <a:ext cx="180000" cy="180000"/>
+                </a:xfrm>
+                <a:prstGeom prst="ellipse">
+                  <a:avLst/>
+                </a:prstGeom>
+                <a:noFill/>
+                <a:ln>
+                  <a:solidFill>
+                    <a:schemeClr val="tx1"/>
+                  </a:solidFill>
+                </a:ln>
+              </p:spPr>
+              <p:style>
+                <a:lnRef idx="2">
+                  <a:schemeClr val="accent1">
+                    <a:shade val="15000"/>
+                  </a:schemeClr>
+                </a:lnRef>
+                <a:fillRef idx="1">
+                  <a:schemeClr val="accent1"/>
+                </a:fillRef>
+                <a:effectRef idx="0">
+                  <a:schemeClr val="accent1"/>
+                </a:effectRef>
+                <a:fontRef idx="minor">
+                  <a:schemeClr val="lt1"/>
+                </a:fontRef>
+              </p:style>
+              <p:txBody>
+                <a:bodyPr rtlCol="0" anchor="ctr"/>
+                <a:lstStyle/>
+                <a:p>
+                  <a:pPr algn="ctr"/>
+                  <a:endParaRPr lang="fr-FR" dirty="0"/>
+                </a:p>
+              </p:txBody>
+            </p:sp>
+          </p:grpSp>
+        </p:grpSp>
       </p:grpSp>
     </p:spTree>
     <p:extLst>

</xml_diff>